<commit_message>
feat: strengthen agentic recovery and evaluation evidence
</commit_message>
<xml_diff>
--- a/presentation/08079_이형진_최종발표.pptx
+++ b/presentation/08079_이형진_최종발표.pptx
@@ -2,16 +2,16 @@
 <file path=ppt/presentation.xml><?xml version="1.0" encoding="utf-8"?>
 <p:presentation xmlns:p="http://schemas.openxmlformats.org/presentationml/2006/main">
   <p:sldMasterIdLst>
-    <p:sldMasterId xmlns:r="http://schemas.openxmlformats.org/officeDocument/2006/relationships" id="2147483648" r:id="Rde27b0afab3f4689"/>
+    <p:sldMasterId xmlns:r="http://schemas.openxmlformats.org/officeDocument/2006/relationships" id="2147483648" r:id="Rc447007474b94603"/>
   </p:sldMasterIdLst>
   <p:notesMasterIdLst>
-    <p:notesMasterId xmlns:r="http://schemas.openxmlformats.org/officeDocument/2006/relationships" r:id="Rdfa3f58aa65f4a66"/>
+    <p:notesMasterId xmlns:r="http://schemas.openxmlformats.org/officeDocument/2006/relationships" r:id="R9acfe2c54ed44d68"/>
   </p:notesMasterIdLst>
   <p:sldIdLst>
-    <p:sldId xmlns:r="http://schemas.openxmlformats.org/officeDocument/2006/relationships" id="256" r:id="R91b60a1f830344ba"/>
-    <p:sldId xmlns:r="http://schemas.openxmlformats.org/officeDocument/2006/relationships" id="257" r:id="Rc25d05947e0c4b8f"/>
-    <p:sldId xmlns:r="http://schemas.openxmlformats.org/officeDocument/2006/relationships" id="258" r:id="Re187a24129be43b4"/>
-    <p:sldId xmlns:r="http://schemas.openxmlformats.org/officeDocument/2006/relationships" id="259" r:id="R93e3670bacc4452d"/>
+    <p:sldId xmlns:r="http://schemas.openxmlformats.org/officeDocument/2006/relationships" id="256" r:id="Rfab069d8bc2c48bb"/>
+    <p:sldId xmlns:r="http://schemas.openxmlformats.org/officeDocument/2006/relationships" id="257" r:id="R7d0dfb23c6514ddd"/>
+    <p:sldId xmlns:r="http://schemas.openxmlformats.org/officeDocument/2006/relationships" id="258" r:id="R785e3ae6dacf414e"/>
+    <p:sldId xmlns:r="http://schemas.openxmlformats.org/officeDocument/2006/relationships" id="259" r:id="Rc1a9cc26f7da42af"/>
   </p:sldIdLst>
   <p:sldSz cx="9144000" cy="5143500"/>
   <p:notesSz cx="6858000" cy="9144000"/>
@@ -885,7 +885,7 @@
   </p:cSld>
   <p:clrMap bg1="lt1" tx1="dk1" bg2="lt2" tx2="dk2" accent1="accent1" accent2="accent2" accent3="accent3" accent4="accent4" accent5="accent5" accent6="accent6" hlink="hlink" folHlink="folHlink"/>
   <p:sldLayoutIdLst>
-    <p:sldLayoutId xmlns:r="http://schemas.openxmlformats.org/officeDocument/2006/relationships" id="2147483649" r:id="R916eff4b88954d83"/>
+    <p:sldLayoutId xmlns:r="http://schemas.openxmlformats.org/officeDocument/2006/relationships" id="2147483649" r:id="Ra4ba806bf5f04a77"/>
   </p:sldLayoutIdLst>
   <p:hf sldNum="0" hdr="0" ftr="0" dt="0"/>
   <p:txStyles>
@@ -1483,9 +1483,10 @@
             <a:prstDash val="solid"/>
           </a:ln>
         </p:spPr>
-        <p:txBody xmlns:a="http://schemas.openxmlformats.org/drawingml/2006/main">
-          <a:bodyPr/>
-          <a:p/>
+        <p:txBody>
+          <a:bodyPr xmlns:a="http://schemas.openxmlformats.org/drawingml/2006/main"/>
+          <a:lstStyle xmlns:a="http://schemas.openxmlformats.org/drawingml/2006/main"/>
+          <a:p xmlns:a="http://schemas.openxmlformats.org/drawingml/2006/main"/>
         </p:txBody>
       </p:sp>
       <p:sp>
@@ -1626,9 +1627,10 @@
             <a:prstDash val="solid"/>
           </a:ln>
         </p:spPr>
-        <p:txBody xmlns:a="http://schemas.openxmlformats.org/drawingml/2006/main">
-          <a:bodyPr/>
-          <a:p/>
+        <p:txBody>
+          <a:bodyPr xmlns:a="http://schemas.openxmlformats.org/drawingml/2006/main"/>
+          <a:lstStyle xmlns:a="http://schemas.openxmlformats.org/drawingml/2006/main"/>
+          <a:p xmlns:a="http://schemas.openxmlformats.org/drawingml/2006/main"/>
         </p:txBody>
       </p:sp>
       <p:sp>
@@ -1899,9 +1901,10 @@
             <a:prstDash val="solid"/>
           </a:ln>
         </p:spPr>
-        <p:txBody xmlns:a="http://schemas.openxmlformats.org/drawingml/2006/main">
-          <a:bodyPr/>
-          <a:p/>
+        <p:txBody>
+          <a:bodyPr xmlns:a="http://schemas.openxmlformats.org/drawingml/2006/main"/>
+          <a:lstStyle xmlns:a="http://schemas.openxmlformats.org/drawingml/2006/main"/>
+          <a:p xmlns:a="http://schemas.openxmlformats.org/drawingml/2006/main"/>
         </p:txBody>
       </p:sp>
     </p:spTree>
@@ -1965,9 +1968,10 @@
             <a:prstDash val="solid"/>
           </a:ln>
         </p:spPr>
-        <p:txBody xmlns:a="http://schemas.openxmlformats.org/drawingml/2006/main">
-          <a:bodyPr/>
-          <a:p/>
+        <p:txBody>
+          <a:bodyPr xmlns:a="http://schemas.openxmlformats.org/drawingml/2006/main"/>
+          <a:lstStyle xmlns:a="http://schemas.openxmlformats.org/drawingml/2006/main"/>
+          <a:p xmlns:a="http://schemas.openxmlformats.org/drawingml/2006/main"/>
         </p:txBody>
       </p:sp>
       <p:sp>
@@ -2055,9 +2059,10 @@
             <a:prstDash val="solid"/>
           </a:ln>
         </p:spPr>
-        <p:txBody xmlns:a="http://schemas.openxmlformats.org/drawingml/2006/main">
-          <a:bodyPr/>
-          <a:p/>
+        <p:txBody>
+          <a:bodyPr xmlns:a="http://schemas.openxmlformats.org/drawingml/2006/main"/>
+          <a:lstStyle xmlns:a="http://schemas.openxmlformats.org/drawingml/2006/main"/>
+          <a:p xmlns:a="http://schemas.openxmlformats.org/drawingml/2006/main"/>
         </p:txBody>
       </p:sp>
       <p:sp>
@@ -2143,9 +2148,10 @@
             <a:prstDash val="solid"/>
           </a:ln>
         </p:spPr>
-        <p:txBody xmlns:a="http://schemas.openxmlformats.org/drawingml/2006/main">
-          <a:bodyPr/>
-          <a:p/>
+        <p:txBody>
+          <a:bodyPr xmlns:a="http://schemas.openxmlformats.org/drawingml/2006/main"/>
+          <a:lstStyle xmlns:a="http://schemas.openxmlformats.org/drawingml/2006/main"/>
+          <a:p xmlns:a="http://schemas.openxmlformats.org/drawingml/2006/main"/>
         </p:txBody>
       </p:sp>
       <p:sp>
@@ -2180,9 +2186,10 @@
             <a:prstDash val="solid"/>
           </a:ln>
         </p:spPr>
-        <p:txBody xmlns:a="http://schemas.openxmlformats.org/drawingml/2006/main">
-          <a:bodyPr/>
-          <a:p/>
+        <p:txBody>
+          <a:bodyPr xmlns:a="http://schemas.openxmlformats.org/drawingml/2006/main"/>
+          <a:lstStyle xmlns:a="http://schemas.openxmlformats.org/drawingml/2006/main"/>
+          <a:p xmlns:a="http://schemas.openxmlformats.org/drawingml/2006/main"/>
         </p:txBody>
       </p:sp>
       <p:sp>
@@ -2262,9 +2269,10 @@
             <a:prstDash val="solid"/>
           </a:ln>
         </p:spPr>
-        <p:txBody xmlns:a="http://schemas.openxmlformats.org/drawingml/2006/main">
-          <a:bodyPr/>
-          <a:p/>
+        <p:txBody>
+          <a:bodyPr xmlns:a="http://schemas.openxmlformats.org/drawingml/2006/main"/>
+          <a:lstStyle xmlns:a="http://schemas.openxmlformats.org/drawingml/2006/main"/>
+          <a:p xmlns:a="http://schemas.openxmlformats.org/drawingml/2006/main"/>
         </p:txBody>
       </p:sp>
       <p:sp>
@@ -2299,9 +2307,10 @@
             <a:prstDash val="solid"/>
           </a:ln>
         </p:spPr>
-        <p:txBody xmlns:a="http://schemas.openxmlformats.org/drawingml/2006/main">
-          <a:bodyPr/>
-          <a:p/>
+        <p:txBody>
+          <a:bodyPr xmlns:a="http://schemas.openxmlformats.org/drawingml/2006/main"/>
+          <a:lstStyle xmlns:a="http://schemas.openxmlformats.org/drawingml/2006/main"/>
+          <a:p xmlns:a="http://schemas.openxmlformats.org/drawingml/2006/main"/>
         </p:txBody>
       </p:sp>
       <p:sp>
@@ -2530,9 +2539,10 @@
             <a:prstDash val="solid"/>
           </a:ln>
         </p:spPr>
-        <p:txBody xmlns:a="http://schemas.openxmlformats.org/drawingml/2006/main">
-          <a:bodyPr/>
-          <a:p/>
+        <p:txBody>
+          <a:bodyPr xmlns:a="http://schemas.openxmlformats.org/drawingml/2006/main"/>
+          <a:lstStyle xmlns:a="http://schemas.openxmlformats.org/drawingml/2006/main"/>
+          <a:p xmlns:a="http://schemas.openxmlformats.org/drawingml/2006/main"/>
         </p:txBody>
       </p:sp>
       <p:sp>
@@ -2567,9 +2577,10 @@
             <a:prstDash val="solid"/>
           </a:ln>
         </p:spPr>
-        <p:txBody xmlns:a="http://schemas.openxmlformats.org/drawingml/2006/main">
-          <a:bodyPr/>
-          <a:p/>
+        <p:txBody>
+          <a:bodyPr xmlns:a="http://schemas.openxmlformats.org/drawingml/2006/main"/>
+          <a:lstStyle xmlns:a="http://schemas.openxmlformats.org/drawingml/2006/main"/>
+          <a:p xmlns:a="http://schemas.openxmlformats.org/drawingml/2006/main"/>
         </p:txBody>
       </p:sp>
       <p:sp>
@@ -2907,9 +2918,10 @@
             <a:prstDash val="solid"/>
           </a:ln>
         </p:spPr>
-        <p:txBody xmlns:a="http://schemas.openxmlformats.org/drawingml/2006/main">
-          <a:bodyPr/>
-          <a:p/>
+        <p:txBody>
+          <a:bodyPr xmlns:a="http://schemas.openxmlformats.org/drawingml/2006/main"/>
+          <a:lstStyle xmlns:a="http://schemas.openxmlformats.org/drawingml/2006/main"/>
+          <a:p xmlns:a="http://schemas.openxmlformats.org/drawingml/2006/main"/>
         </p:txBody>
       </p:sp>
       <p:sp>
@@ -3021,9 +3033,10 @@
             <a:prstDash val="solid"/>
           </a:ln>
         </p:spPr>
-        <p:txBody xmlns:a="http://schemas.openxmlformats.org/drawingml/2006/main">
-          <a:bodyPr/>
-          <a:p/>
+        <p:txBody>
+          <a:bodyPr xmlns:a="http://schemas.openxmlformats.org/drawingml/2006/main"/>
+          <a:lstStyle xmlns:a="http://schemas.openxmlformats.org/drawingml/2006/main"/>
+          <a:p xmlns:a="http://schemas.openxmlformats.org/drawingml/2006/main"/>
         </p:txBody>
       </p:sp>
       <p:sp>
@@ -3074,7 +3087,7 @@
                 <a:ea typeface="맑은 고딕"/>
                 <a:cs typeface="맑은 고딕"/>
               </a:rPr>
-              <a:t>83.3 → 100%</a:t>
+              <a:t>78.6 → 100%</a:t>
             </a:r>
           </a:p>
           <a:p xmlns:a="http://schemas.openxmlformats.org/drawingml/2006/main">
@@ -3098,7 +3111,7 @@
                 <a:ea typeface="맑은 고딕"/>
                 <a:cs typeface="맑은 고딕"/>
               </a:rPr>
-              <a:t>업무 성공률 · 고정 LLM→Agentic (n=12)</a:t>
+              <a:t>업무 성공률 · Fixed→Agentic (n=14)</a:t>
             </a:r>
           </a:p>
         </p:txBody>
@@ -3135,9 +3148,10 @@
             <a:prstDash val="solid"/>
           </a:ln>
         </p:spPr>
-        <p:txBody xmlns:a="http://schemas.openxmlformats.org/drawingml/2006/main">
-          <a:bodyPr/>
-          <a:p/>
+        <p:txBody>
+          <a:bodyPr xmlns:a="http://schemas.openxmlformats.org/drawingml/2006/main"/>
+          <a:lstStyle xmlns:a="http://schemas.openxmlformats.org/drawingml/2006/main"/>
+          <a:p xmlns:a="http://schemas.openxmlformats.org/drawingml/2006/main"/>
         </p:txBody>
       </p:sp>
       <p:sp>
@@ -3188,7 +3202,7 @@
                 <a:ea typeface="맑은 고딕"/>
                 <a:cs typeface="맑은 고딕"/>
               </a:rPr>
-              <a:t>~23배</a:t>
+              <a:t>0 → 100%</a:t>
             </a:r>
           </a:p>
           <a:p xmlns:a="http://schemas.openxmlformats.org/drawingml/2006/main">
@@ -3212,7 +3226,7 @@
                 <a:ea typeface="맑은 고딕"/>
                 <a:cs typeface="맑은 고딕"/>
               </a:rPr>
-              <a:t>사람 수동 대비 처리시간 · 분석적 추정</a:t>
+              <a:t>구조 실패 안전복구 · 3개 시나리오</a:t>
             </a:r>
           </a:p>
         </p:txBody>
@@ -3249,9 +3263,10 @@
             <a:prstDash val="solid"/>
           </a:ln>
         </p:spPr>
-        <p:txBody xmlns:a="http://schemas.openxmlformats.org/drawingml/2006/main">
-          <a:bodyPr/>
-          <a:p/>
+        <p:txBody>
+          <a:bodyPr xmlns:a="http://schemas.openxmlformats.org/drawingml/2006/main"/>
+          <a:lstStyle xmlns:a="http://schemas.openxmlformats.org/drawingml/2006/main"/>
+          <a:p xmlns:a="http://schemas.openxmlformats.org/drawingml/2006/main"/>
         </p:txBody>
       </p:sp>
       <p:sp>
@@ -3437,9 +3452,10 @@
             <a:prstDash val="solid"/>
           </a:ln>
         </p:spPr>
-        <p:txBody xmlns:a="http://schemas.openxmlformats.org/drawingml/2006/main">
-          <a:bodyPr/>
-          <a:p/>
+        <p:txBody>
+          <a:bodyPr xmlns:a="http://schemas.openxmlformats.org/drawingml/2006/main"/>
+          <a:lstStyle xmlns:a="http://schemas.openxmlformats.org/drawingml/2006/main"/>
+          <a:p xmlns:a="http://schemas.openxmlformats.org/drawingml/2006/main"/>
         </p:txBody>
       </p:sp>
       <p:sp>
@@ -3527,9 +3543,10 @@
             <a:prstDash val="solid"/>
           </a:ln>
         </p:spPr>
-        <p:txBody xmlns:a="http://schemas.openxmlformats.org/drawingml/2006/main">
-          <a:bodyPr/>
-          <a:p/>
+        <p:txBody>
+          <a:bodyPr xmlns:a="http://schemas.openxmlformats.org/drawingml/2006/main"/>
+          <a:lstStyle xmlns:a="http://schemas.openxmlformats.org/drawingml/2006/main"/>
+          <a:p xmlns:a="http://schemas.openxmlformats.org/drawingml/2006/main"/>
         </p:txBody>
       </p:sp>
       <p:sp>
@@ -3615,9 +3632,10 @@
             <a:prstDash val="solid"/>
           </a:ln>
         </p:spPr>
-        <p:txBody xmlns:a="http://schemas.openxmlformats.org/drawingml/2006/main">
-          <a:bodyPr/>
-          <a:p/>
+        <p:txBody>
+          <a:bodyPr xmlns:a="http://schemas.openxmlformats.org/drawingml/2006/main"/>
+          <a:lstStyle xmlns:a="http://schemas.openxmlformats.org/drawingml/2006/main"/>
+          <a:p xmlns:a="http://schemas.openxmlformats.org/drawingml/2006/main"/>
         </p:txBody>
       </p:sp>
       <p:sp>
@@ -3652,9 +3670,10 @@
             <a:prstDash val="solid"/>
           </a:ln>
         </p:spPr>
-        <p:txBody xmlns:a="http://schemas.openxmlformats.org/drawingml/2006/main">
-          <a:bodyPr/>
-          <a:p/>
+        <p:txBody>
+          <a:bodyPr xmlns:a="http://schemas.openxmlformats.org/drawingml/2006/main"/>
+          <a:lstStyle xmlns:a="http://schemas.openxmlformats.org/drawingml/2006/main"/>
+          <a:p xmlns:a="http://schemas.openxmlformats.org/drawingml/2006/main"/>
         </p:txBody>
       </p:sp>
       <p:sp>
@@ -3734,9 +3753,10 @@
             <a:prstDash val="sysDash"/>
           </a:ln>
         </p:spPr>
-        <p:txBody xmlns:a="http://schemas.openxmlformats.org/drawingml/2006/main">
-          <a:bodyPr/>
-          <a:p/>
+        <p:txBody>
+          <a:bodyPr xmlns:a="http://schemas.openxmlformats.org/drawingml/2006/main"/>
+          <a:lstStyle xmlns:a="http://schemas.openxmlformats.org/drawingml/2006/main"/>
+          <a:p xmlns:a="http://schemas.openxmlformats.org/drawingml/2006/main"/>
         </p:txBody>
       </p:sp>
       <p:sp>
@@ -4003,7 +4023,7 @@
                 <a:ea typeface="맑은 고딕"/>
                 <a:cs typeface="맑은 고딕"/>
               </a:rPr>
-              <a:t>Submission/Correction → Validate → Reject/Merge</a:t>
+              <a:t>Submission/Correction → Contract → Validate → Self-Correct → Reject/Merge</a:t>
             </a:r>
           </a:p>
           <a:p xmlns:a="http://schemas.openxmlformats.org/drawingml/2006/main">
@@ -4197,6 +4217,7 @@
           <a:lstStyle xmlns:a="http://schemas.openxmlformats.org/drawingml/2006/main"/>
           <a:p xmlns:a="http://schemas.openxmlformats.org/drawingml/2006/main">
             <a:pPr algn="ctr">
+              <a:buNone/>
               <a:defRPr sz="938" b="1">
                 <a:solidFill>
                   <a:srgbClr val="666666"/>
@@ -4215,7 +4236,7 @@
                 <a:ea typeface="맑은 고딕"/>
                 <a:cs typeface="맑은 고딕"/>
               </a:rPr>
-              <a:t>LLM 판단(Supervisor·ToT 규칙 후보 선택, Yao 2023) ↔ deterministic 실행(검증·Policy Gate) 경계</a:t>
+              <a:t>LLM 판단(Supervisor·메일 해석·교정 제안) ↔ 코드 확정(검증 계약·Policy Gate)</a:t>
             </a:r>
           </a:p>
         </p:txBody>
@@ -4252,9 +4273,10 @@
             <a:prstDash val="solid"/>
           </a:ln>
         </p:spPr>
-        <p:txBody xmlns:a="http://schemas.openxmlformats.org/drawingml/2006/main">
-          <a:bodyPr/>
-          <a:p/>
+        <p:txBody>
+          <a:bodyPr xmlns:a="http://schemas.openxmlformats.org/drawingml/2006/main"/>
+          <a:lstStyle xmlns:a="http://schemas.openxmlformats.org/drawingml/2006/main"/>
+          <a:p xmlns:a="http://schemas.openxmlformats.org/drawingml/2006/main"/>
         </p:txBody>
       </p:sp>
       <p:sp>
@@ -4289,9 +4311,10 @@
             <a:prstDash val="solid"/>
           </a:ln>
         </p:spPr>
-        <p:txBody xmlns:a="http://schemas.openxmlformats.org/drawingml/2006/main">
-          <a:bodyPr/>
-          <a:p/>
+        <p:txBody>
+          <a:bodyPr xmlns:a="http://schemas.openxmlformats.org/drawingml/2006/main"/>
+          <a:lstStyle xmlns:a="http://schemas.openxmlformats.org/drawingml/2006/main"/>
+          <a:p xmlns:a="http://schemas.openxmlformats.org/drawingml/2006/main"/>
         </p:txBody>
       </p:sp>
       <p:sp>
@@ -4326,9 +4349,10 @@
             <a:prstDash val="solid"/>
           </a:ln>
         </p:spPr>
-        <p:txBody xmlns:a="http://schemas.openxmlformats.org/drawingml/2006/main">
-          <a:bodyPr/>
-          <a:p/>
+        <p:txBody>
+          <a:bodyPr xmlns:a="http://schemas.openxmlformats.org/drawingml/2006/main"/>
+          <a:lstStyle xmlns:a="http://schemas.openxmlformats.org/drawingml/2006/main"/>
+          <a:p xmlns:a="http://schemas.openxmlformats.org/drawingml/2006/main"/>
         </p:txBody>
       </p:sp>
       <p:sp>
@@ -4477,7 +4501,7 @@
                 <a:ea typeface="맑은 고딕"/>
                 <a:cs typeface="맑은 고딕"/>
               </a:rPr>
-              <a:t>선택 이유: 고정 Python 체인은 실패 후 다음 행동을 바꾸지 못함</a:t>
+              <a:t>선택 이유: 고정 체인은 Worker 실패 후 다음 행동을 바꾸지 못함</a:t>
             </a:r>
           </a:p>
           <a:p xmlns:a="http://schemas.openxmlformats.org/drawingml/2006/main">
@@ -4501,7 +4525,7 @@
                 <a:ea typeface="맑은 고딕"/>
                 <a:cs typeface="맑은 고딕"/>
               </a:rPr>
-              <a:t>측정: Fixed 83.3% → Agentic 100% 성공, 위험행동 0 유지 (n=12)</a:t>
+              <a:t>측정: Fixed 78.6% → Agentic 100%; 실패복구 0→100%(3/3), 지연 +40% (n=14)</a:t>
             </a:r>
           </a:p>
         </p:txBody>
@@ -4538,9 +4562,10 @@
             <a:prstDash val="solid"/>
           </a:ln>
         </p:spPr>
-        <p:txBody xmlns:a="http://schemas.openxmlformats.org/drawingml/2006/main">
-          <a:bodyPr/>
-          <a:p/>
+        <p:txBody>
+          <a:bodyPr xmlns:a="http://schemas.openxmlformats.org/drawingml/2006/main"/>
+          <a:lstStyle xmlns:a="http://schemas.openxmlformats.org/drawingml/2006/main"/>
+          <a:p xmlns:a="http://schemas.openxmlformats.org/drawingml/2006/main"/>
         </p:txBody>
       </p:sp>
       <p:sp>
@@ -4575,9 +4600,10 @@
             <a:prstDash val="solid"/>
           </a:ln>
         </p:spPr>
-        <p:txBody xmlns:a="http://schemas.openxmlformats.org/drawingml/2006/main">
-          <a:bodyPr/>
-          <a:p/>
+        <p:txBody>
+          <a:bodyPr xmlns:a="http://schemas.openxmlformats.org/drawingml/2006/main"/>
+          <a:lstStyle xmlns:a="http://schemas.openxmlformats.org/drawingml/2006/main"/>
+          <a:p xmlns:a="http://schemas.openxmlformats.org/drawingml/2006/main"/>
         </p:txBody>
       </p:sp>
       <p:sp>
@@ -4612,9 +4638,10 @@
             <a:prstDash val="solid"/>
           </a:ln>
         </p:spPr>
-        <p:txBody xmlns:a="http://schemas.openxmlformats.org/drawingml/2006/main">
-          <a:bodyPr/>
-          <a:p/>
+        <p:txBody>
+          <a:bodyPr xmlns:a="http://schemas.openxmlformats.org/drawingml/2006/main"/>
+          <a:lstStyle xmlns:a="http://schemas.openxmlformats.org/drawingml/2006/main"/>
+          <a:p xmlns:a="http://schemas.openxmlformats.org/drawingml/2006/main"/>
         </p:txBody>
       </p:sp>
       <p:sp>
@@ -4824,9 +4851,10 @@
             <a:prstDash val="solid"/>
           </a:ln>
         </p:spPr>
-        <p:txBody xmlns:a="http://schemas.openxmlformats.org/drawingml/2006/main">
-          <a:bodyPr/>
-          <a:p/>
+        <p:txBody>
+          <a:bodyPr xmlns:a="http://schemas.openxmlformats.org/drawingml/2006/main"/>
+          <a:lstStyle xmlns:a="http://schemas.openxmlformats.org/drawingml/2006/main"/>
+          <a:p xmlns:a="http://schemas.openxmlformats.org/drawingml/2006/main"/>
         </p:txBody>
       </p:sp>
       <p:sp>
@@ -4861,9 +4889,10 @@
             <a:prstDash val="solid"/>
           </a:ln>
         </p:spPr>
-        <p:txBody xmlns:a="http://schemas.openxmlformats.org/drawingml/2006/main">
-          <a:bodyPr/>
-          <a:p/>
+        <p:txBody>
+          <a:bodyPr xmlns:a="http://schemas.openxmlformats.org/drawingml/2006/main"/>
+          <a:lstStyle xmlns:a="http://schemas.openxmlformats.org/drawingml/2006/main"/>
+          <a:p xmlns:a="http://schemas.openxmlformats.org/drawingml/2006/main"/>
         </p:txBody>
       </p:sp>
       <p:sp>
@@ -4898,9 +4927,10 @@
             <a:prstDash val="solid"/>
           </a:ln>
         </p:spPr>
-        <p:txBody xmlns:a="http://schemas.openxmlformats.org/drawingml/2006/main">
-          <a:bodyPr/>
-          <a:p/>
+        <p:txBody>
+          <a:bodyPr xmlns:a="http://schemas.openxmlformats.org/drawingml/2006/main"/>
+          <a:lstStyle xmlns:a="http://schemas.openxmlformats.org/drawingml/2006/main"/>
+          <a:p xmlns:a="http://schemas.openxmlformats.org/drawingml/2006/main"/>
         </p:txBody>
       </p:sp>
       <p:sp>
@@ -4996,7 +5026,7 @@
                 <a:ea typeface="맑은 고딕"/>
                 <a:cs typeface="맑은 고딕"/>
               </a:rPr>
-              <a:t>Rule Validator + Policy Gate</a:t>
+              <a:t>Rule Validator + Correction Gate</a:t>
             </a:r>
           </a:p>
         </p:txBody>
@@ -5139,9 +5169,10 @@
             <a:prstDash val="solid"/>
           </a:ln>
         </p:spPr>
-        <p:txBody xmlns:a="http://schemas.openxmlformats.org/drawingml/2006/main">
-          <a:bodyPr/>
-          <a:p/>
+        <p:txBody>
+          <a:bodyPr xmlns:a="http://schemas.openxmlformats.org/drawingml/2006/main"/>
+          <a:lstStyle xmlns:a="http://schemas.openxmlformats.org/drawingml/2006/main"/>
+          <a:p xmlns:a="http://schemas.openxmlformats.org/drawingml/2006/main"/>
         </p:txBody>
       </p:sp>
       <p:sp>
@@ -5229,9 +5260,10 @@
             <a:prstDash val="solid"/>
           </a:ln>
         </p:spPr>
-        <p:txBody xmlns:a="http://schemas.openxmlformats.org/drawingml/2006/main">
-          <a:bodyPr/>
-          <a:p/>
+        <p:txBody>
+          <a:bodyPr xmlns:a="http://schemas.openxmlformats.org/drawingml/2006/main"/>
+          <a:lstStyle xmlns:a="http://schemas.openxmlformats.org/drawingml/2006/main"/>
+          <a:p xmlns:a="http://schemas.openxmlformats.org/drawingml/2006/main"/>
         </p:txBody>
       </p:sp>
       <p:sp>
@@ -5317,9 +5349,10 @@
             <a:prstDash val="solid"/>
           </a:ln>
         </p:spPr>
-        <p:txBody xmlns:a="http://schemas.openxmlformats.org/drawingml/2006/main">
-          <a:bodyPr/>
-          <a:p/>
+        <p:txBody>
+          <a:bodyPr xmlns:a="http://schemas.openxmlformats.org/drawingml/2006/main"/>
+          <a:lstStyle xmlns:a="http://schemas.openxmlformats.org/drawingml/2006/main"/>
+          <a:p xmlns:a="http://schemas.openxmlformats.org/drawingml/2006/main"/>
         </p:txBody>
       </p:sp>
       <p:sp>
@@ -5354,9 +5387,10 @@
             <a:prstDash val="solid"/>
           </a:ln>
         </p:spPr>
-        <p:txBody xmlns:a="http://schemas.openxmlformats.org/drawingml/2006/main">
-          <a:bodyPr/>
-          <a:p/>
+        <p:txBody>
+          <a:bodyPr xmlns:a="http://schemas.openxmlformats.org/drawingml/2006/main"/>
+          <a:lstStyle xmlns:a="http://schemas.openxmlformats.org/drawingml/2006/main"/>
+          <a:p xmlns:a="http://schemas.openxmlformats.org/drawingml/2006/main"/>
         </p:txBody>
       </p:sp>
       <p:sp>
@@ -5436,9 +5470,10 @@
             <a:prstDash val="solid"/>
           </a:ln>
         </p:spPr>
-        <p:txBody xmlns:a="http://schemas.openxmlformats.org/drawingml/2006/main">
-          <a:bodyPr/>
-          <a:p/>
+        <p:txBody>
+          <a:bodyPr xmlns:a="http://schemas.openxmlformats.org/drawingml/2006/main"/>
+          <a:lstStyle xmlns:a="http://schemas.openxmlformats.org/drawingml/2006/main"/>
+          <a:p xmlns:a="http://schemas.openxmlformats.org/drawingml/2006/main"/>
         </p:txBody>
       </p:sp>
       <p:sp>
@@ -5579,9 +5614,10 @@
             <a:prstDash val="solid"/>
           </a:ln>
         </p:spPr>
-        <p:txBody xmlns:a="http://schemas.openxmlformats.org/drawingml/2006/main">
-          <a:bodyPr/>
-          <a:p/>
+        <p:txBody>
+          <a:bodyPr xmlns:a="http://schemas.openxmlformats.org/drawingml/2006/main"/>
+          <a:lstStyle xmlns:a="http://schemas.openxmlformats.org/drawingml/2006/main"/>
+          <a:p xmlns:a="http://schemas.openxmlformats.org/drawingml/2006/main"/>
         </p:txBody>
       </p:sp>
       <p:sp>
@@ -5616,9 +5652,10 @@
             <a:prstDash val="solid"/>
           </a:ln>
         </p:spPr>
-        <p:txBody xmlns:a="http://schemas.openxmlformats.org/drawingml/2006/main">
-          <a:bodyPr/>
-          <a:p/>
+        <p:txBody>
+          <a:bodyPr xmlns:a="http://schemas.openxmlformats.org/drawingml/2006/main"/>
+          <a:lstStyle xmlns:a="http://schemas.openxmlformats.org/drawingml/2006/main"/>
+          <a:p xmlns:a="http://schemas.openxmlformats.org/drawingml/2006/main"/>
         </p:txBody>
       </p:sp>
       <p:sp>
@@ -5794,7 +5831,7 @@
                 <a:ea typeface="맑은 고딕"/>
                 <a:cs typeface="맑은 고딕"/>
               </a:rPr>
-              <a:t>• Worker 실패를 observation으로 되돌려 재계획 (Self-Correction 루프, Madaan 2023)</a:t>
+              <a:t>• Worker 실패를 observation으로 반환해 Supervisor가 재계획</a:t>
             </a:r>
           </a:p>
           <a:p xmlns:a="http://schemas.openxmlformats.org/drawingml/2006/main">
@@ -5994,7 +6031,7 @@
                 <a:ea typeface="맑은 고딕"/>
                 <a:cs typeface="맑은 고딕"/>
               </a:rPr>
-              <a:t>12개 적대 시나리오의 기능 검증. 사람 대비 ROI는 분석적 추정(~23배·~96%↓, docs/roi_manual_estimate.md)이며 실측 CSV로 대체 가능합니다.</a:t>
+              <a:t>14개 동일-capability 비교. 사람 ROI는 미측정(roi_claim_available=false).</a:t>
             </a:r>
           </a:p>
         </p:txBody>
@@ -6031,9 +6068,10 @@
             <a:prstDash val="solid"/>
           </a:ln>
         </p:spPr>
-        <p:txBody xmlns:a="http://schemas.openxmlformats.org/drawingml/2006/main">
-          <a:bodyPr/>
-          <a:p/>
+        <p:txBody>
+          <a:bodyPr xmlns:a="http://schemas.openxmlformats.org/drawingml/2006/main"/>
+          <a:lstStyle xmlns:a="http://schemas.openxmlformats.org/drawingml/2006/main"/>
+          <a:p xmlns:a="http://schemas.openxmlformats.org/drawingml/2006/main"/>
         </p:txBody>
       </p:sp>
       <p:sp>
@@ -6068,9 +6106,10 @@
             <a:prstDash val="solid"/>
           </a:ln>
         </p:spPr>
-        <p:txBody xmlns:a="http://schemas.openxmlformats.org/drawingml/2006/main">
-          <a:bodyPr/>
-          <a:p/>
+        <p:txBody>
+          <a:bodyPr xmlns:a="http://schemas.openxmlformats.org/drawingml/2006/main"/>
+          <a:lstStyle xmlns:a="http://schemas.openxmlformats.org/drawingml/2006/main"/>
+          <a:p xmlns:a="http://schemas.openxmlformats.org/drawingml/2006/main"/>
         </p:txBody>
       </p:sp>
       <p:sp>
@@ -6121,7 +6160,7 @@
                 <a:ea typeface="맑은 고딕"/>
                 <a:cs typeface="맑은 고딕"/>
               </a:rPr>
-              <a:t>결과 및 성과 (Live LLM, n=12)</a:t>
+              <a:t>결과 및 성과 (Live LLM, n=14)</a:t>
             </a:r>
           </a:p>
         </p:txBody>
@@ -6158,9 +6197,10 @@
             <a:prstDash val="solid"/>
           </a:ln>
         </p:spPr>
-        <p:txBody xmlns:a="http://schemas.openxmlformats.org/drawingml/2006/main">
-          <a:bodyPr/>
-          <a:p/>
+        <p:txBody>
+          <a:bodyPr xmlns:a="http://schemas.openxmlformats.org/drawingml/2006/main"/>
+          <a:lstStyle xmlns:a="http://schemas.openxmlformats.org/drawingml/2006/main"/>
+          <a:p xmlns:a="http://schemas.openxmlformats.org/drawingml/2006/main"/>
         </p:txBody>
       </p:sp>
       <p:sp>
@@ -6246,9 +6286,10 @@
             <a:prstDash val="solid"/>
           </a:ln>
         </p:spPr>
-        <p:txBody xmlns:a="http://schemas.openxmlformats.org/drawingml/2006/main">
-          <a:bodyPr/>
-          <a:p/>
+        <p:txBody>
+          <a:bodyPr xmlns:a="http://schemas.openxmlformats.org/drawingml/2006/main"/>
+          <a:lstStyle xmlns:a="http://schemas.openxmlformats.org/drawingml/2006/main"/>
+          <a:p xmlns:a="http://schemas.openxmlformats.org/drawingml/2006/main"/>
         </p:txBody>
       </p:sp>
       <p:sp>
@@ -6360,9 +6401,10 @@
             <a:prstDash val="solid"/>
           </a:ln>
         </p:spPr>
-        <p:txBody xmlns:a="http://schemas.openxmlformats.org/drawingml/2006/main">
-          <a:bodyPr/>
-          <a:p/>
+        <p:txBody>
+          <a:bodyPr xmlns:a="http://schemas.openxmlformats.org/drawingml/2006/main"/>
+          <a:lstStyle xmlns:a="http://schemas.openxmlformats.org/drawingml/2006/main"/>
+          <a:p xmlns:a="http://schemas.openxmlformats.org/drawingml/2006/main"/>
         </p:txBody>
       </p:sp>
       <p:sp>
@@ -6448,9 +6490,10 @@
             <a:prstDash val="solid"/>
           </a:ln>
         </p:spPr>
-        <p:txBody xmlns:a="http://schemas.openxmlformats.org/drawingml/2006/main">
-          <a:bodyPr/>
-          <a:p/>
+        <p:txBody>
+          <a:bodyPr xmlns:a="http://schemas.openxmlformats.org/drawingml/2006/main"/>
+          <a:lstStyle xmlns:a="http://schemas.openxmlformats.org/drawingml/2006/main"/>
+          <a:p xmlns:a="http://schemas.openxmlformats.org/drawingml/2006/main"/>
         </p:txBody>
       </p:sp>
       <p:sp>
@@ -6501,7 +6544,7 @@
                 <a:ea typeface="맑은 고딕"/>
                 <a:cs typeface="맑은 고딕"/>
               </a:rPr>
-              <a:t>업무 성공률 · 고정 LLM→Agentic (n=12)</a:t>
+              <a:t>업무 성공률 · Fixed→Agentic (n=14)</a:t>
             </a:r>
           </a:p>
           <a:p xmlns:a="http://schemas.openxmlformats.org/drawingml/2006/main">
@@ -6525,7 +6568,7 @@
                 <a:ea typeface="맑은 고딕"/>
                 <a:cs typeface="맑은 고딕"/>
               </a:rPr>
-              <a:t>Fixed Workflow 83.3% 대비 +16.7%p</a:t>
+              <a:t>Fixed 78.6% 대비 +21.4%p</a:t>
             </a:r>
           </a:p>
         </p:txBody>
@@ -6562,9 +6605,10 @@
             <a:prstDash val="solid"/>
           </a:ln>
         </p:spPr>
-        <p:txBody xmlns:a="http://schemas.openxmlformats.org/drawingml/2006/main">
-          <a:bodyPr/>
-          <a:p/>
+        <p:txBody>
+          <a:bodyPr xmlns:a="http://schemas.openxmlformats.org/drawingml/2006/main"/>
+          <a:lstStyle xmlns:a="http://schemas.openxmlformats.org/drawingml/2006/main"/>
+          <a:p xmlns:a="http://schemas.openxmlformats.org/drawingml/2006/main"/>
         </p:txBody>
       </p:sp>
       <p:sp>
@@ -6615,7 +6659,7 @@
                 <a:ea typeface="맑은 고딕"/>
                 <a:cs typeface="맑은 고딕"/>
               </a:rPr>
-              <a:t>0건</a:t>
+              <a:t>100%</a:t>
             </a:r>
           </a:p>
         </p:txBody>
@@ -6650,9 +6694,10 @@
             <a:prstDash val="solid"/>
           </a:ln>
         </p:spPr>
-        <p:txBody xmlns:a="http://schemas.openxmlformats.org/drawingml/2006/main">
-          <a:bodyPr/>
-          <a:p/>
+        <p:txBody>
+          <a:bodyPr xmlns:a="http://schemas.openxmlformats.org/drawingml/2006/main"/>
+          <a:lstStyle xmlns:a="http://schemas.openxmlformats.org/drawingml/2006/main"/>
+          <a:p xmlns:a="http://schemas.openxmlformats.org/drawingml/2006/main"/>
         </p:txBody>
       </p:sp>
       <p:sp>
@@ -6703,7 +6748,7 @@
                 <a:ea typeface="맑은 고딕"/>
                 <a:cs typeface="맑은 고딕"/>
               </a:rPr>
-              <a:t>위험 행동</a:t>
+              <a:t>구조 실패 안전복구 · 3/3</a:t>
             </a:r>
           </a:p>
           <a:p xmlns:a="http://schemas.openxmlformats.org/drawingml/2006/main">
@@ -6727,7 +6772,7 @@
                 <a:ea typeface="맑은 고딕"/>
                 <a:cs typeface="맑은 고딕"/>
               </a:rPr>
-              <a:t>3개 아키텍처 전 구간 0건 · Policy Gate 공유</a:t>
+              <a:t>Fixed 0% → Agentic 100% · 배치 지연 +40%</a:t>
             </a:r>
           </a:p>
         </p:txBody>

</xml_diff>